<commit_message>
fix: images de la presentation en JPEG (PNG non affichees par PowerPoint)
Les cartes et le schema etaient embarques en PNG et affichaient
"impossible d'afficher l'image" dans PowerPoint (cadres vides qui se
superposaient au texte). Conversion en JPEG -> affichage correct.
Verifie par export PowerPoint des slides 8 et 10.
</commit_message>
<xml_diff>
--- a/docs/exports/soutenance-workshop-pv.pptx
+++ b/docs/exports/soutenance-workshop-pv.pptx
@@ -4688,7 +4688,7 @@
       </p:sp>
       <p:pic>
         <p:nvPicPr>
-          <p:cNvPr id="3" name="Picture 2" descr="schema-complet.png"/>
+          <p:cNvPr id="3" name="Picture 2" descr="schema-complet.jpg"/>
           <p:cNvPicPr>
             <a:picLocks noChangeAspect="1"/>
           </p:cNvPicPr>
@@ -10257,7 +10257,7 @@
       </p:sp>
       <p:pic>
         <p:nvPicPr>
-          <p:cNvPr id="3" name="Picture 2" descr="carte_facteur.png"/>
+          <p:cNvPr id="3" name="Picture 2" descr="carte_facteur.jpg"/>
           <p:cNvPicPr>
             <a:picLocks noChangeAspect="1"/>
           </p:cNvPicPr>
@@ -10272,7 +10272,7 @@
         <p:spPr>
           <a:xfrm>
             <a:off x="2011680" y="1371600"/>
-            <a:ext cx="2567815" cy="2057400"/>
+            <a:ext cx="2568136" cy="2057400"/>
           </a:xfrm>
           <a:prstGeom prst="rect">
             <a:avLst/>
@@ -10288,7 +10288,7 @@
         <p:spPr>
           <a:xfrm>
             <a:off x="1737360" y="3474720"/>
-            <a:ext cx="3116455" cy="320040"/>
+            <a:ext cx="3116776" cy="320040"/>
           </a:xfrm>
           <a:prstGeom prst="rect">
             <a:avLst/>
@@ -10323,7 +10323,7 @@
       </p:sp>
       <p:pic>
         <p:nvPicPr>
-          <p:cNvPr id="5" name="Picture 4" descr="carte_lcoe.png"/>
+          <p:cNvPr id="5" name="Picture 4" descr="carte_lcoe.jpg"/>
           <p:cNvPicPr>
             <a:picLocks noChangeAspect="1"/>
           </p:cNvPicPr>
@@ -10338,7 +10338,7 @@
         <p:spPr>
           <a:xfrm>
             <a:off x="7680960" y="1371600"/>
-            <a:ext cx="2522845" cy="2057400"/>
+            <a:ext cx="2524772" cy="2057400"/>
           </a:xfrm>
           <a:prstGeom prst="rect">
             <a:avLst/>
@@ -10354,7 +10354,7 @@
         <p:spPr>
           <a:xfrm>
             <a:off x="7406640" y="3474720"/>
-            <a:ext cx="3071485" cy="320040"/>
+            <a:ext cx="3073412" cy="320040"/>
           </a:xfrm>
           <a:prstGeom prst="rect">
             <a:avLst/>
@@ -10389,7 +10389,7 @@
       </p:sp>
       <p:pic>
         <p:nvPicPr>
-          <p:cNvPr id="7" name="Picture 6" descr="carte_payback.png"/>
+          <p:cNvPr id="7" name="Picture 6" descr="carte_payback.jpg"/>
           <p:cNvPicPr>
             <a:picLocks noChangeAspect="1"/>
           </p:cNvPicPr>
@@ -10404,7 +10404,7 @@
         <p:spPr>
           <a:xfrm>
             <a:off x="2011680" y="3931920"/>
-            <a:ext cx="2552075" cy="2057400"/>
+            <a:ext cx="2553681" cy="2057400"/>
           </a:xfrm>
           <a:prstGeom prst="rect">
             <a:avLst/>
@@ -10420,7 +10420,7 @@
         <p:spPr>
           <a:xfrm>
             <a:off x="1737360" y="6035040"/>
-            <a:ext cx="3100715" cy="320040"/>
+            <a:ext cx="3102321" cy="320040"/>
           </a:xfrm>
           <a:prstGeom prst="rect">
             <a:avLst/>
@@ -10455,7 +10455,7 @@
       </p:sp>
       <p:pic>
         <p:nvPicPr>
-          <p:cNvPr id="9" name="Picture 8" descr="carte_tri.png"/>
+          <p:cNvPr id="9" name="Picture 8" descr="carte_tri.jpg"/>
           <p:cNvPicPr>
             <a:picLocks noChangeAspect="1"/>
           </p:cNvPicPr>
@@ -10470,7 +10470,7 @@
         <p:spPr>
           <a:xfrm>
             <a:off x="7680960" y="3931920"/>
-            <a:ext cx="2507105" cy="2057400"/>
+            <a:ext cx="2507908" cy="2057400"/>
           </a:xfrm>
           <a:prstGeom prst="rect">
             <a:avLst/>
@@ -10486,7 +10486,7 @@
         <p:spPr>
           <a:xfrm>
             <a:off x="7406640" y="6035040"/>
-            <a:ext cx="3055745" cy="320040"/>
+            <a:ext cx="3056548" cy="320040"/>
           </a:xfrm>
           <a:prstGeom prst="rect">
             <a:avLst/>

</xml_diff>

<commit_message>
docs: slide hypotheses cles + sources (justifier les chiffres du modele)
</commit_message>
<xml_diff>
--- a/docs/exports/soutenance-workshop-pv.pptx
+++ b/docs/exports/soutenance-workshop-pv.pptx
@@ -14,6 +14,7 @@
     <p:sldId id="259" r:id="rId5"/>
     <p:sldId id="260" r:id="rId6"/>
     <p:sldId id="261" r:id="rId7"/>
+    <p:sldId id="269" r:id="rId20"/>
     <p:sldId id="262" r:id="rId8"/>
     <p:sldId id="263" r:id="rId9"/>
     <p:sldId id="264" r:id="rId10"/>
@@ -5512,6 +5513,2141 @@
                 <a:latin typeface="Calibri"/>
               </a:rPr>
               <a:t>·   Workshop client — Oxand   ·   MBA M2 Big Data &amp; IA</a:t>
+            </a:r>
+          </a:p>
+        </p:txBody>
+      </p:sp>
+    </p:spTree>
+  </p:cSld>
+  <p:clrMapOvr>
+    <a:masterClrMapping/>
+  </p:clrMapOvr>
+</p:sld>
+</file>
+
+<file path=ppt/slides/slide13.xml><?xml version="1.0" encoding="utf-8"?>
+<p:sld xmlns:a="http://schemas.openxmlformats.org/drawingml/2006/main" xmlns:p="http://schemas.openxmlformats.org/presentationml/2006/main" xmlns:r="http://schemas.openxmlformats.org/officeDocument/2006/relationships">
+  <p:cSld>
+    <p:bg>
+      <p:bgPr>
+        <a:solidFill>
+          <a:srgbClr val="FFFFFF"/>
+        </a:solidFill>
+        <a:effectLst/>
+      </p:bgPr>
+    </p:bg>
+    <p:spTree>
+      <p:nvGrpSpPr>
+        <p:cNvPr id="1" name=""/>
+        <p:cNvGrpSpPr/>
+        <p:nvPr/>
+      </p:nvGrpSpPr>
+      <p:grpSpPr/>
+      <p:sp>
+        <p:nvSpPr>
+          <p:cNvPr id="2" name="TextBox 1"/>
+          <p:cNvSpPr txBox="1"/>
+          <p:nvPr/>
+        </p:nvSpPr>
+        <p:spPr>
+          <a:xfrm>
+            <a:off x="914400" y="640080"/>
+            <a:ext cx="10972800" cy="822960"/>
+          </a:xfrm>
+          <a:prstGeom prst="rect">
+            <a:avLst/>
+          </a:prstGeom>
+          <a:noFill/>
+        </p:spPr>
+        <p:txBody>
+          <a:bodyPr wrap="square" anchor="t" lIns="0" rIns="0" tIns="0" bIns="0">
+            <a:spAutoFit/>
+          </a:bodyPr>
+          <a:lstStyle/>
+          <a:p>
+            <a:pPr algn="l">
+              <a:spcAft>
+                <a:spcPts val="0"/>
+              </a:spcAft>
+            </a:pPr>
+            <a:r>
+              <a:rPr sz="3000" b="1">
+                <a:solidFill>
+                  <a:srgbClr val="12293D"/>
+                </a:solidFill>
+                <a:latin typeface="Cambria"/>
+              </a:rPr>
+              <a:t>Les hypothèses clés — et d'où elles viennent</a:t>
+            </a:r>
+          </a:p>
+        </p:txBody>
+      </p:sp>
+      <p:sp>
+        <p:nvSpPr>
+          <p:cNvPr id="3" name="TextBox 2"/>
+          <p:cNvSpPr txBox="1"/>
+          <p:nvPr/>
+        </p:nvSpPr>
+        <p:spPr>
+          <a:xfrm>
+            <a:off x="914400" y="1508760"/>
+            <a:ext cx="10424160" cy="457200"/>
+          </a:xfrm>
+          <a:prstGeom prst="rect">
+            <a:avLst/>
+          </a:prstGeom>
+          <a:noFill/>
+        </p:spPr>
+        <p:txBody>
+          <a:bodyPr wrap="square" anchor="t" lIns="0" rIns="0" tIns="0" bIns="0">
+            <a:spAutoFit/>
+          </a:bodyPr>
+          <a:lstStyle/>
+          <a:p>
+            <a:pPr algn="l">
+              <a:spcAft>
+                <a:spcPts val="0"/>
+              </a:spcAft>
+            </a:pPr>
+            <a:r>
+              <a:rPr sz="1400" b="0">
+                <a:solidFill>
+                  <a:srgbClr val="647486"/>
+                </a:solidFill>
+                <a:latin typeface="Calibri"/>
+              </a:rPr>
+              <a:t>Tous les chiffres du modèle sont explicites et assumés comme des hypothèses.</a:t>
+            </a:r>
+          </a:p>
+        </p:txBody>
+      </p:sp>
+      <p:sp>
+        <p:nvSpPr>
+          <p:cNvPr id="4" name="Rectangle 3"/>
+          <p:cNvSpPr/>
+          <p:nvPr/>
+        </p:nvSpPr>
+        <p:spPr>
+          <a:xfrm>
+            <a:off x="914400" y="2148840"/>
+            <a:ext cx="3657600" cy="457200"/>
+          </a:xfrm>
+          <a:prstGeom prst="rect">
+            <a:avLst/>
+          </a:prstGeom>
+          <a:solidFill>
+            <a:srgbClr val="12293D"/>
+          </a:solidFill>
+          <a:ln>
+            <a:noFill/>
+          </a:ln>
+          <a:effectLst/>
+        </p:spPr>
+        <p:style>
+          <a:lnRef idx="1">
+            <a:schemeClr val="accent1"/>
+          </a:lnRef>
+          <a:fillRef idx="3">
+            <a:schemeClr val="accent1"/>
+          </a:fillRef>
+          <a:effectRef idx="2">
+            <a:schemeClr val="accent1"/>
+          </a:effectRef>
+          <a:fontRef idx="minor">
+            <a:schemeClr val="lt1"/>
+          </a:fontRef>
+        </p:style>
+        <p:txBody>
+          <a:bodyPr rtlCol="0" anchor="ctr"/>
+          <a:lstStyle/>
+          <a:p>
+            <a:pPr algn="ctr"/>
+          </a:p>
+        </p:txBody>
+      </p:sp>
+      <p:sp>
+        <p:nvSpPr>
+          <p:cNvPr id="5" name="TextBox 4"/>
+          <p:cNvSpPr txBox="1"/>
+          <p:nvPr/>
+        </p:nvSpPr>
+        <p:spPr>
+          <a:xfrm>
+            <a:off x="1051560" y="2148840"/>
+            <a:ext cx="3383280" cy="457200"/>
+          </a:xfrm>
+          <a:prstGeom prst="rect">
+            <a:avLst/>
+          </a:prstGeom>
+          <a:noFill/>
+        </p:spPr>
+        <p:txBody>
+          <a:bodyPr wrap="square" anchor="ctr" lIns="0" rIns="0" tIns="0" bIns="0">
+            <a:spAutoFit/>
+          </a:bodyPr>
+          <a:lstStyle/>
+          <a:p>
+            <a:pPr algn="l">
+              <a:spcAft>
+                <a:spcPts val="0"/>
+              </a:spcAft>
+            </a:pPr>
+            <a:r>
+              <a:rPr sz="1250" b="1">
+                <a:solidFill>
+                  <a:srgbClr val="FFFFFF"/>
+                </a:solidFill>
+                <a:latin typeface="Calibri"/>
+              </a:rPr>
+              <a:t>Hypothèse</a:t>
+            </a:r>
+          </a:p>
+        </p:txBody>
+      </p:sp>
+      <p:sp>
+        <p:nvSpPr>
+          <p:cNvPr id="6" name="Rectangle 5"/>
+          <p:cNvSpPr/>
+          <p:nvPr/>
+        </p:nvSpPr>
+        <p:spPr>
+          <a:xfrm>
+            <a:off x="4572000" y="2148840"/>
+            <a:ext cx="2377440" cy="457200"/>
+          </a:xfrm>
+          <a:prstGeom prst="rect">
+            <a:avLst/>
+          </a:prstGeom>
+          <a:solidFill>
+            <a:srgbClr val="12293D"/>
+          </a:solidFill>
+          <a:ln>
+            <a:noFill/>
+          </a:ln>
+          <a:effectLst/>
+        </p:spPr>
+        <p:style>
+          <a:lnRef idx="1">
+            <a:schemeClr val="accent1"/>
+          </a:lnRef>
+          <a:fillRef idx="3">
+            <a:schemeClr val="accent1"/>
+          </a:fillRef>
+          <a:effectRef idx="2">
+            <a:schemeClr val="accent1"/>
+          </a:effectRef>
+          <a:fontRef idx="minor">
+            <a:schemeClr val="lt1"/>
+          </a:fontRef>
+        </p:style>
+        <p:txBody>
+          <a:bodyPr rtlCol="0" anchor="ctr"/>
+          <a:lstStyle/>
+          <a:p>
+            <a:pPr algn="ctr"/>
+          </a:p>
+        </p:txBody>
+      </p:sp>
+      <p:sp>
+        <p:nvSpPr>
+          <p:cNvPr id="7" name="TextBox 6"/>
+          <p:cNvSpPr txBox="1"/>
+          <p:nvPr/>
+        </p:nvSpPr>
+        <p:spPr>
+          <a:xfrm>
+            <a:off x="4709160" y="2148840"/>
+            <a:ext cx="2103120" cy="457200"/>
+          </a:xfrm>
+          <a:prstGeom prst="rect">
+            <a:avLst/>
+          </a:prstGeom>
+          <a:noFill/>
+        </p:spPr>
+        <p:txBody>
+          <a:bodyPr wrap="square" anchor="ctr" lIns="0" rIns="0" tIns="0" bIns="0">
+            <a:spAutoFit/>
+          </a:bodyPr>
+          <a:lstStyle/>
+          <a:p>
+            <a:pPr algn="l">
+              <a:spcAft>
+                <a:spcPts val="0"/>
+              </a:spcAft>
+            </a:pPr>
+            <a:r>
+              <a:rPr sz="1250" b="1">
+                <a:solidFill>
+                  <a:srgbClr val="FFFFFF"/>
+                </a:solidFill>
+                <a:latin typeface="Calibri"/>
+              </a:rPr>
+              <a:t>Valeur</a:t>
+            </a:r>
+          </a:p>
+        </p:txBody>
+      </p:sp>
+      <p:sp>
+        <p:nvSpPr>
+          <p:cNvPr id="8" name="Rectangle 7"/>
+          <p:cNvSpPr/>
+          <p:nvPr/>
+        </p:nvSpPr>
+        <p:spPr>
+          <a:xfrm>
+            <a:off x="6949440" y="2148840"/>
+            <a:ext cx="4389120" cy="457200"/>
+          </a:xfrm>
+          <a:prstGeom prst="rect">
+            <a:avLst/>
+          </a:prstGeom>
+          <a:solidFill>
+            <a:srgbClr val="12293D"/>
+          </a:solidFill>
+          <a:ln>
+            <a:noFill/>
+          </a:ln>
+          <a:effectLst/>
+        </p:spPr>
+        <p:style>
+          <a:lnRef idx="1">
+            <a:schemeClr val="accent1"/>
+          </a:lnRef>
+          <a:fillRef idx="3">
+            <a:schemeClr val="accent1"/>
+          </a:fillRef>
+          <a:effectRef idx="2">
+            <a:schemeClr val="accent1"/>
+          </a:effectRef>
+          <a:fontRef idx="minor">
+            <a:schemeClr val="lt1"/>
+          </a:fontRef>
+        </p:style>
+        <p:txBody>
+          <a:bodyPr rtlCol="0" anchor="ctr"/>
+          <a:lstStyle/>
+          <a:p>
+            <a:pPr algn="ctr"/>
+          </a:p>
+        </p:txBody>
+      </p:sp>
+      <p:sp>
+        <p:nvSpPr>
+          <p:cNvPr id="9" name="TextBox 8"/>
+          <p:cNvSpPr txBox="1"/>
+          <p:nvPr/>
+        </p:nvSpPr>
+        <p:spPr>
+          <a:xfrm>
+            <a:off x="7086600" y="2148840"/>
+            <a:ext cx="4114800" cy="457200"/>
+          </a:xfrm>
+          <a:prstGeom prst="rect">
+            <a:avLst/>
+          </a:prstGeom>
+          <a:noFill/>
+        </p:spPr>
+        <p:txBody>
+          <a:bodyPr wrap="square" anchor="ctr" lIns="0" rIns="0" tIns="0" bIns="0">
+            <a:spAutoFit/>
+          </a:bodyPr>
+          <a:lstStyle/>
+          <a:p>
+            <a:pPr algn="l">
+              <a:spcAft>
+                <a:spcPts val="0"/>
+              </a:spcAft>
+            </a:pPr>
+            <a:r>
+              <a:rPr sz="1250" b="1">
+                <a:solidFill>
+                  <a:srgbClr val="FFFFFF"/>
+                </a:solidFill>
+                <a:latin typeface="Calibri"/>
+              </a:rPr>
+              <a:t>D'où ça vient</a:t>
+            </a:r>
+          </a:p>
+        </p:txBody>
+      </p:sp>
+      <p:sp>
+        <p:nvSpPr>
+          <p:cNvPr id="10" name="Rectangle 9"/>
+          <p:cNvSpPr/>
+          <p:nvPr/>
+        </p:nvSpPr>
+        <p:spPr>
+          <a:xfrm>
+            <a:off x="914400" y="2606040"/>
+            <a:ext cx="3657600" cy="475488"/>
+          </a:xfrm>
+          <a:prstGeom prst="rect">
+            <a:avLst/>
+          </a:prstGeom>
+          <a:solidFill>
+            <a:srgbClr val="F5F8F7"/>
+          </a:solidFill>
+          <a:ln>
+            <a:noFill/>
+          </a:ln>
+          <a:effectLst/>
+        </p:spPr>
+        <p:style>
+          <a:lnRef idx="1">
+            <a:schemeClr val="accent1"/>
+          </a:lnRef>
+          <a:fillRef idx="3">
+            <a:schemeClr val="accent1"/>
+          </a:fillRef>
+          <a:effectRef idx="2">
+            <a:schemeClr val="accent1"/>
+          </a:effectRef>
+          <a:fontRef idx="minor">
+            <a:schemeClr val="lt1"/>
+          </a:fontRef>
+        </p:style>
+        <p:txBody>
+          <a:bodyPr rtlCol="0" anchor="ctr"/>
+          <a:lstStyle/>
+          <a:p>
+            <a:pPr algn="ctr"/>
+          </a:p>
+        </p:txBody>
+      </p:sp>
+      <p:sp>
+        <p:nvSpPr>
+          <p:cNvPr id="11" name="TextBox 10"/>
+          <p:cNvSpPr txBox="1"/>
+          <p:nvPr/>
+        </p:nvSpPr>
+        <p:spPr>
+          <a:xfrm>
+            <a:off x="1051560" y="2606040"/>
+            <a:ext cx="3383280" cy="475488"/>
+          </a:xfrm>
+          <a:prstGeom prst="rect">
+            <a:avLst/>
+          </a:prstGeom>
+          <a:noFill/>
+        </p:spPr>
+        <p:txBody>
+          <a:bodyPr wrap="square" anchor="ctr" lIns="0" rIns="0" tIns="0" bIns="0">
+            <a:spAutoFit/>
+          </a:bodyPr>
+          <a:lstStyle/>
+          <a:p>
+            <a:pPr algn="l">
+              <a:spcAft>
+                <a:spcPts val="0"/>
+              </a:spcAft>
+            </a:pPr>
+            <a:r>
+              <a:rPr sz="1150" b="0">
+                <a:solidFill>
+                  <a:srgbClr val="222B36"/>
+                </a:solidFill>
+                <a:latin typeface="Calibri"/>
+              </a:rPr>
+              <a:t>Durée de vie analysée</a:t>
+            </a:r>
+          </a:p>
+        </p:txBody>
+      </p:sp>
+      <p:sp>
+        <p:nvSpPr>
+          <p:cNvPr id="12" name="Rectangle 11"/>
+          <p:cNvSpPr/>
+          <p:nvPr/>
+        </p:nvSpPr>
+        <p:spPr>
+          <a:xfrm>
+            <a:off x="4572000" y="2606040"/>
+            <a:ext cx="2377440" cy="475488"/>
+          </a:xfrm>
+          <a:prstGeom prst="rect">
+            <a:avLst/>
+          </a:prstGeom>
+          <a:solidFill>
+            <a:srgbClr val="F5F8F7"/>
+          </a:solidFill>
+          <a:ln>
+            <a:noFill/>
+          </a:ln>
+          <a:effectLst/>
+        </p:spPr>
+        <p:style>
+          <a:lnRef idx="1">
+            <a:schemeClr val="accent1"/>
+          </a:lnRef>
+          <a:fillRef idx="3">
+            <a:schemeClr val="accent1"/>
+          </a:fillRef>
+          <a:effectRef idx="2">
+            <a:schemeClr val="accent1"/>
+          </a:effectRef>
+          <a:fontRef idx="minor">
+            <a:schemeClr val="lt1"/>
+          </a:fontRef>
+        </p:style>
+        <p:txBody>
+          <a:bodyPr rtlCol="0" anchor="ctr"/>
+          <a:lstStyle/>
+          <a:p>
+            <a:pPr algn="ctr"/>
+          </a:p>
+        </p:txBody>
+      </p:sp>
+      <p:sp>
+        <p:nvSpPr>
+          <p:cNvPr id="13" name="TextBox 12"/>
+          <p:cNvSpPr txBox="1"/>
+          <p:nvPr/>
+        </p:nvSpPr>
+        <p:spPr>
+          <a:xfrm>
+            <a:off x="4709160" y="2606040"/>
+            <a:ext cx="2103120" cy="475488"/>
+          </a:xfrm>
+          <a:prstGeom prst="rect">
+            <a:avLst/>
+          </a:prstGeom>
+          <a:noFill/>
+        </p:spPr>
+        <p:txBody>
+          <a:bodyPr wrap="square" anchor="ctr" lIns="0" rIns="0" tIns="0" bIns="0">
+            <a:spAutoFit/>
+          </a:bodyPr>
+          <a:lstStyle/>
+          <a:p>
+            <a:pPr algn="l">
+              <a:spcAft>
+                <a:spcPts val="0"/>
+              </a:spcAft>
+            </a:pPr>
+            <a:r>
+              <a:rPr sz="1150" b="1">
+                <a:solidFill>
+                  <a:srgbClr val="0E7C7B"/>
+                </a:solidFill>
+                <a:latin typeface="Calibri"/>
+              </a:rPr>
+              <a:t>25 ans</a:t>
+            </a:r>
+          </a:p>
+        </p:txBody>
+      </p:sp>
+      <p:sp>
+        <p:nvSpPr>
+          <p:cNvPr id="14" name="Rectangle 13"/>
+          <p:cNvSpPr/>
+          <p:nvPr/>
+        </p:nvSpPr>
+        <p:spPr>
+          <a:xfrm>
+            <a:off x="6949440" y="2606040"/>
+            <a:ext cx="4389120" cy="475488"/>
+          </a:xfrm>
+          <a:prstGeom prst="rect">
+            <a:avLst/>
+          </a:prstGeom>
+          <a:solidFill>
+            <a:srgbClr val="F5F8F7"/>
+          </a:solidFill>
+          <a:ln>
+            <a:noFill/>
+          </a:ln>
+          <a:effectLst/>
+        </p:spPr>
+        <p:style>
+          <a:lnRef idx="1">
+            <a:schemeClr val="accent1"/>
+          </a:lnRef>
+          <a:fillRef idx="3">
+            <a:schemeClr val="accent1"/>
+          </a:fillRef>
+          <a:effectRef idx="2">
+            <a:schemeClr val="accent1"/>
+          </a:effectRef>
+          <a:fontRef idx="minor">
+            <a:schemeClr val="lt1"/>
+          </a:fontRef>
+        </p:style>
+        <p:txBody>
+          <a:bodyPr rtlCol="0" anchor="ctr"/>
+          <a:lstStyle/>
+          <a:p>
+            <a:pPr algn="ctr"/>
+          </a:p>
+        </p:txBody>
+      </p:sp>
+      <p:sp>
+        <p:nvSpPr>
+          <p:cNvPr id="15" name="TextBox 14"/>
+          <p:cNvSpPr txBox="1"/>
+          <p:nvPr/>
+        </p:nvSpPr>
+        <p:spPr>
+          <a:xfrm>
+            <a:off x="7086600" y="2606040"/>
+            <a:ext cx="4114800" cy="475488"/>
+          </a:xfrm>
+          <a:prstGeom prst="rect">
+            <a:avLst/>
+          </a:prstGeom>
+          <a:noFill/>
+        </p:spPr>
+        <p:txBody>
+          <a:bodyPr wrap="square" anchor="ctr" lIns="0" rIns="0" tIns="0" bIns="0">
+            <a:spAutoFit/>
+          </a:bodyPr>
+          <a:lstStyle/>
+          <a:p>
+            <a:pPr algn="l">
+              <a:spcAft>
+                <a:spcPts val="0"/>
+              </a:spcAft>
+            </a:pPr>
+            <a:r>
+              <a:rPr sz="1150" b="0">
+                <a:solidFill>
+                  <a:srgbClr val="222B36"/>
+                </a:solidFill>
+                <a:latin typeface="Calibri"/>
+              </a:rPr>
+              <a:t>Durée de vie standard des panneaux</a:t>
+            </a:r>
+          </a:p>
+        </p:txBody>
+      </p:sp>
+      <p:sp>
+        <p:nvSpPr>
+          <p:cNvPr id="16" name="Rectangle 15"/>
+          <p:cNvSpPr/>
+          <p:nvPr/>
+        </p:nvSpPr>
+        <p:spPr>
+          <a:xfrm>
+            <a:off x="914400" y="3081528"/>
+            <a:ext cx="3657600" cy="475488"/>
+          </a:xfrm>
+          <a:prstGeom prst="rect">
+            <a:avLst/>
+          </a:prstGeom>
+          <a:solidFill>
+            <a:srgbClr val="FFFFFF"/>
+          </a:solidFill>
+          <a:ln>
+            <a:noFill/>
+          </a:ln>
+          <a:effectLst/>
+        </p:spPr>
+        <p:style>
+          <a:lnRef idx="1">
+            <a:schemeClr val="accent1"/>
+          </a:lnRef>
+          <a:fillRef idx="3">
+            <a:schemeClr val="accent1"/>
+          </a:fillRef>
+          <a:effectRef idx="2">
+            <a:schemeClr val="accent1"/>
+          </a:effectRef>
+          <a:fontRef idx="minor">
+            <a:schemeClr val="lt1"/>
+          </a:fontRef>
+        </p:style>
+        <p:txBody>
+          <a:bodyPr rtlCol="0" anchor="ctr"/>
+          <a:lstStyle/>
+          <a:p>
+            <a:pPr algn="ctr"/>
+          </a:p>
+        </p:txBody>
+      </p:sp>
+      <p:sp>
+        <p:nvSpPr>
+          <p:cNvPr id="17" name="TextBox 16"/>
+          <p:cNvSpPr txBox="1"/>
+          <p:nvPr/>
+        </p:nvSpPr>
+        <p:spPr>
+          <a:xfrm>
+            <a:off x="1051560" y="3081528"/>
+            <a:ext cx="3383280" cy="475488"/>
+          </a:xfrm>
+          <a:prstGeom prst="rect">
+            <a:avLst/>
+          </a:prstGeom>
+          <a:noFill/>
+        </p:spPr>
+        <p:txBody>
+          <a:bodyPr wrap="square" anchor="ctr" lIns="0" rIns="0" tIns="0" bIns="0">
+            <a:spAutoFit/>
+          </a:bodyPr>
+          <a:lstStyle/>
+          <a:p>
+            <a:pPr algn="l">
+              <a:spcAft>
+                <a:spcPts val="0"/>
+              </a:spcAft>
+            </a:pPr>
+            <a:r>
+              <a:rPr sz="1150" b="0">
+                <a:solidFill>
+                  <a:srgbClr val="222B36"/>
+                </a:solidFill>
+                <a:latin typeface="Calibri"/>
+              </a:rPr>
+              <a:t>Prix de l'électricité réseau</a:t>
+            </a:r>
+          </a:p>
+        </p:txBody>
+      </p:sp>
+      <p:sp>
+        <p:nvSpPr>
+          <p:cNvPr id="18" name="Rectangle 17"/>
+          <p:cNvSpPr/>
+          <p:nvPr/>
+        </p:nvSpPr>
+        <p:spPr>
+          <a:xfrm>
+            <a:off x="4572000" y="3081528"/>
+            <a:ext cx="2377440" cy="475488"/>
+          </a:xfrm>
+          <a:prstGeom prst="rect">
+            <a:avLst/>
+          </a:prstGeom>
+          <a:solidFill>
+            <a:srgbClr val="FFFFFF"/>
+          </a:solidFill>
+          <a:ln>
+            <a:noFill/>
+          </a:ln>
+          <a:effectLst/>
+        </p:spPr>
+        <p:style>
+          <a:lnRef idx="1">
+            <a:schemeClr val="accent1"/>
+          </a:lnRef>
+          <a:fillRef idx="3">
+            <a:schemeClr val="accent1"/>
+          </a:fillRef>
+          <a:effectRef idx="2">
+            <a:schemeClr val="accent1"/>
+          </a:effectRef>
+          <a:fontRef idx="minor">
+            <a:schemeClr val="lt1"/>
+          </a:fontRef>
+        </p:style>
+        <p:txBody>
+          <a:bodyPr rtlCol="0" anchor="ctr"/>
+          <a:lstStyle/>
+          <a:p>
+            <a:pPr algn="ctr"/>
+          </a:p>
+        </p:txBody>
+      </p:sp>
+      <p:sp>
+        <p:nvSpPr>
+          <p:cNvPr id="19" name="TextBox 18"/>
+          <p:cNvSpPr txBox="1"/>
+          <p:nvPr/>
+        </p:nvSpPr>
+        <p:spPr>
+          <a:xfrm>
+            <a:off x="4709160" y="3081528"/>
+            <a:ext cx="2103120" cy="475488"/>
+          </a:xfrm>
+          <a:prstGeom prst="rect">
+            <a:avLst/>
+          </a:prstGeom>
+          <a:noFill/>
+        </p:spPr>
+        <p:txBody>
+          <a:bodyPr wrap="square" anchor="ctr" lIns="0" rIns="0" tIns="0" bIns="0">
+            <a:spAutoFit/>
+          </a:bodyPr>
+          <a:lstStyle/>
+          <a:p>
+            <a:pPr algn="l">
+              <a:spcAft>
+                <a:spcPts val="0"/>
+              </a:spcAft>
+            </a:pPr>
+            <a:r>
+              <a:rPr sz="1150" b="1">
+                <a:solidFill>
+                  <a:srgbClr val="0E7C7B"/>
+                </a:solidFill>
+                <a:latin typeface="Calibri"/>
+              </a:rPr>
+              <a:t>~20 c/kWh</a:t>
+            </a:r>
+          </a:p>
+        </p:txBody>
+      </p:sp>
+      <p:sp>
+        <p:nvSpPr>
+          <p:cNvPr id="20" name="Rectangle 19"/>
+          <p:cNvSpPr/>
+          <p:nvPr/>
+        </p:nvSpPr>
+        <p:spPr>
+          <a:xfrm>
+            <a:off x="6949440" y="3081528"/>
+            <a:ext cx="4389120" cy="475488"/>
+          </a:xfrm>
+          <a:prstGeom prst="rect">
+            <a:avLst/>
+          </a:prstGeom>
+          <a:solidFill>
+            <a:srgbClr val="FFFFFF"/>
+          </a:solidFill>
+          <a:ln>
+            <a:noFill/>
+          </a:ln>
+          <a:effectLst/>
+        </p:spPr>
+        <p:style>
+          <a:lnRef idx="1">
+            <a:schemeClr val="accent1"/>
+          </a:lnRef>
+          <a:fillRef idx="3">
+            <a:schemeClr val="accent1"/>
+          </a:fillRef>
+          <a:effectRef idx="2">
+            <a:schemeClr val="accent1"/>
+          </a:effectRef>
+          <a:fontRef idx="minor">
+            <a:schemeClr val="lt1"/>
+          </a:fontRef>
+        </p:style>
+        <p:txBody>
+          <a:bodyPr rtlCol="0" anchor="ctr"/>
+          <a:lstStyle/>
+          <a:p>
+            <a:pPr algn="ctr"/>
+          </a:p>
+        </p:txBody>
+      </p:sp>
+      <p:sp>
+        <p:nvSpPr>
+          <p:cNvPr id="21" name="TextBox 20"/>
+          <p:cNvSpPr txBox="1"/>
+          <p:nvPr/>
+        </p:nvSpPr>
+        <p:spPr>
+          <a:xfrm>
+            <a:off x="7086600" y="3081528"/>
+            <a:ext cx="4114800" cy="475488"/>
+          </a:xfrm>
+          <a:prstGeom prst="rect">
+            <a:avLst/>
+          </a:prstGeom>
+          <a:noFill/>
+        </p:spPr>
+        <p:txBody>
+          <a:bodyPr wrap="square" anchor="ctr" lIns="0" rIns="0" tIns="0" bIns="0">
+            <a:spAutoFit/>
+          </a:bodyPr>
+          <a:lstStyle/>
+          <a:p>
+            <a:pPr algn="l">
+              <a:spcAft>
+                <a:spcPts val="0"/>
+              </a:spcAft>
+            </a:pPr>
+            <a:r>
+              <a:rPr sz="1150" b="0">
+                <a:solidFill>
+                  <a:srgbClr val="222B36"/>
+                </a:solidFill>
+                <a:latin typeface="Calibri"/>
+              </a:rPr>
+              <a:t>Prix moyen évité en tertiaire</a:t>
+            </a:r>
+          </a:p>
+        </p:txBody>
+      </p:sp>
+      <p:sp>
+        <p:nvSpPr>
+          <p:cNvPr id="22" name="Rectangle 21"/>
+          <p:cNvSpPr/>
+          <p:nvPr/>
+        </p:nvSpPr>
+        <p:spPr>
+          <a:xfrm>
+            <a:off x="914400" y="3557016"/>
+            <a:ext cx="3657600" cy="475488"/>
+          </a:xfrm>
+          <a:prstGeom prst="rect">
+            <a:avLst/>
+          </a:prstGeom>
+          <a:solidFill>
+            <a:srgbClr val="F5F8F7"/>
+          </a:solidFill>
+          <a:ln>
+            <a:noFill/>
+          </a:ln>
+          <a:effectLst/>
+        </p:spPr>
+        <p:style>
+          <a:lnRef idx="1">
+            <a:schemeClr val="accent1"/>
+          </a:lnRef>
+          <a:fillRef idx="3">
+            <a:schemeClr val="accent1"/>
+          </a:fillRef>
+          <a:effectRef idx="2">
+            <a:schemeClr val="accent1"/>
+          </a:effectRef>
+          <a:fontRef idx="minor">
+            <a:schemeClr val="lt1"/>
+          </a:fontRef>
+        </p:style>
+        <p:txBody>
+          <a:bodyPr rtlCol="0" anchor="ctr"/>
+          <a:lstStyle/>
+          <a:p>
+            <a:pPr algn="ctr"/>
+          </a:p>
+        </p:txBody>
+      </p:sp>
+      <p:sp>
+        <p:nvSpPr>
+          <p:cNvPr id="23" name="TextBox 22"/>
+          <p:cNvSpPr txBox="1"/>
+          <p:nvPr/>
+        </p:nvSpPr>
+        <p:spPr>
+          <a:xfrm>
+            <a:off x="1051560" y="3557016"/>
+            <a:ext cx="3383280" cy="475488"/>
+          </a:xfrm>
+          <a:prstGeom prst="rect">
+            <a:avLst/>
+          </a:prstGeom>
+          <a:noFill/>
+        </p:spPr>
+        <p:txBody>
+          <a:bodyPr wrap="square" anchor="ctr" lIns="0" rIns="0" tIns="0" bIns="0">
+            <a:spAutoFit/>
+          </a:bodyPr>
+          <a:lstStyle/>
+          <a:p>
+            <a:pPr algn="l">
+              <a:spcAft>
+                <a:spcPts val="0"/>
+              </a:spcAft>
+            </a:pPr>
+            <a:r>
+              <a:rPr sz="1150" b="0">
+                <a:solidFill>
+                  <a:srgbClr val="222B36"/>
+                </a:solidFill>
+                <a:latin typeface="Calibri"/>
+              </a:rPr>
+              <a:t>Tarif de revente</a:t>
+            </a:r>
+          </a:p>
+        </p:txBody>
+      </p:sp>
+      <p:sp>
+        <p:nvSpPr>
+          <p:cNvPr id="24" name="Rectangle 23"/>
+          <p:cNvSpPr/>
+          <p:nvPr/>
+        </p:nvSpPr>
+        <p:spPr>
+          <a:xfrm>
+            <a:off x="4572000" y="3557016"/>
+            <a:ext cx="2377440" cy="475488"/>
+          </a:xfrm>
+          <a:prstGeom prst="rect">
+            <a:avLst/>
+          </a:prstGeom>
+          <a:solidFill>
+            <a:srgbClr val="F5F8F7"/>
+          </a:solidFill>
+          <a:ln>
+            <a:noFill/>
+          </a:ln>
+          <a:effectLst/>
+        </p:spPr>
+        <p:style>
+          <a:lnRef idx="1">
+            <a:schemeClr val="accent1"/>
+          </a:lnRef>
+          <a:fillRef idx="3">
+            <a:schemeClr val="accent1"/>
+          </a:fillRef>
+          <a:effectRef idx="2">
+            <a:schemeClr val="accent1"/>
+          </a:effectRef>
+          <a:fontRef idx="minor">
+            <a:schemeClr val="lt1"/>
+          </a:fontRef>
+        </p:style>
+        <p:txBody>
+          <a:bodyPr rtlCol="0" anchor="ctr"/>
+          <a:lstStyle/>
+          <a:p>
+            <a:pPr algn="ctr"/>
+          </a:p>
+        </p:txBody>
+      </p:sp>
+      <p:sp>
+        <p:nvSpPr>
+          <p:cNvPr id="25" name="TextBox 24"/>
+          <p:cNvSpPr txBox="1"/>
+          <p:nvPr/>
+        </p:nvSpPr>
+        <p:spPr>
+          <a:xfrm>
+            <a:off x="4709160" y="3557016"/>
+            <a:ext cx="2103120" cy="475488"/>
+          </a:xfrm>
+          <a:prstGeom prst="rect">
+            <a:avLst/>
+          </a:prstGeom>
+          <a:noFill/>
+        </p:spPr>
+        <p:txBody>
+          <a:bodyPr wrap="square" anchor="ctr" lIns="0" rIns="0" tIns="0" bIns="0">
+            <a:spAutoFit/>
+          </a:bodyPr>
+          <a:lstStyle/>
+          <a:p>
+            <a:pPr algn="l">
+              <a:spcAft>
+                <a:spcPts val="0"/>
+              </a:spcAft>
+            </a:pPr>
+            <a:r>
+              <a:rPr sz="1150" b="1">
+                <a:solidFill>
+                  <a:srgbClr val="0E7C7B"/>
+                </a:solidFill>
+                <a:latin typeface="Calibri"/>
+              </a:rPr>
+              <a:t>8–13 c/kWh</a:t>
+            </a:r>
+          </a:p>
+        </p:txBody>
+      </p:sp>
+      <p:sp>
+        <p:nvSpPr>
+          <p:cNvPr id="26" name="Rectangle 25"/>
+          <p:cNvSpPr/>
+          <p:nvPr/>
+        </p:nvSpPr>
+        <p:spPr>
+          <a:xfrm>
+            <a:off x="6949440" y="3557016"/>
+            <a:ext cx="4389120" cy="475488"/>
+          </a:xfrm>
+          <a:prstGeom prst="rect">
+            <a:avLst/>
+          </a:prstGeom>
+          <a:solidFill>
+            <a:srgbClr val="F5F8F7"/>
+          </a:solidFill>
+          <a:ln>
+            <a:noFill/>
+          </a:ln>
+          <a:effectLst/>
+        </p:spPr>
+        <p:style>
+          <a:lnRef idx="1">
+            <a:schemeClr val="accent1"/>
+          </a:lnRef>
+          <a:fillRef idx="3">
+            <a:schemeClr val="accent1"/>
+          </a:fillRef>
+          <a:effectRef idx="2">
+            <a:schemeClr val="accent1"/>
+          </a:effectRef>
+          <a:fontRef idx="minor">
+            <a:schemeClr val="lt1"/>
+          </a:fontRef>
+        </p:style>
+        <p:txBody>
+          <a:bodyPr rtlCol="0" anchor="ctr"/>
+          <a:lstStyle/>
+          <a:p>
+            <a:pPr algn="ctr"/>
+          </a:p>
+        </p:txBody>
+      </p:sp>
+      <p:sp>
+        <p:nvSpPr>
+          <p:cNvPr id="27" name="TextBox 26"/>
+          <p:cNvSpPr txBox="1"/>
+          <p:nvPr/>
+        </p:nvSpPr>
+        <p:spPr>
+          <a:xfrm>
+            <a:off x="7086600" y="3557016"/>
+            <a:ext cx="4114800" cy="475488"/>
+          </a:xfrm>
+          <a:prstGeom prst="rect">
+            <a:avLst/>
+          </a:prstGeom>
+          <a:noFill/>
+        </p:spPr>
+        <p:txBody>
+          <a:bodyPr wrap="square" anchor="ctr" lIns="0" rIns="0" tIns="0" bIns="0">
+            <a:spAutoFit/>
+          </a:bodyPr>
+          <a:lstStyle/>
+          <a:p>
+            <a:pPr algn="l">
+              <a:spcAft>
+                <a:spcPts val="0"/>
+              </a:spcAft>
+            </a:pPr>
+            <a:r>
+              <a:rPr sz="1150" b="0">
+                <a:solidFill>
+                  <a:srgbClr val="222B36"/>
+                </a:solidFill>
+                <a:latin typeface="Calibri"/>
+              </a:rPr>
+              <a:t>Arrêté tarifaire S21 (réglementé)</a:t>
+            </a:r>
+          </a:p>
+        </p:txBody>
+      </p:sp>
+      <p:sp>
+        <p:nvSpPr>
+          <p:cNvPr id="28" name="Rectangle 27"/>
+          <p:cNvSpPr/>
+          <p:nvPr/>
+        </p:nvSpPr>
+        <p:spPr>
+          <a:xfrm>
+            <a:off x="914400" y="4032504"/>
+            <a:ext cx="3657600" cy="475488"/>
+          </a:xfrm>
+          <a:prstGeom prst="rect">
+            <a:avLst/>
+          </a:prstGeom>
+          <a:solidFill>
+            <a:srgbClr val="FFFFFF"/>
+          </a:solidFill>
+          <a:ln>
+            <a:noFill/>
+          </a:ln>
+          <a:effectLst/>
+        </p:spPr>
+        <p:style>
+          <a:lnRef idx="1">
+            <a:schemeClr val="accent1"/>
+          </a:lnRef>
+          <a:fillRef idx="3">
+            <a:schemeClr val="accent1"/>
+          </a:fillRef>
+          <a:effectRef idx="2">
+            <a:schemeClr val="accent1"/>
+          </a:effectRef>
+          <a:fontRef idx="minor">
+            <a:schemeClr val="lt1"/>
+          </a:fontRef>
+        </p:style>
+        <p:txBody>
+          <a:bodyPr rtlCol="0" anchor="ctr"/>
+          <a:lstStyle/>
+          <a:p>
+            <a:pPr algn="ctr"/>
+          </a:p>
+        </p:txBody>
+      </p:sp>
+      <p:sp>
+        <p:nvSpPr>
+          <p:cNvPr id="29" name="TextBox 28"/>
+          <p:cNvSpPr txBox="1"/>
+          <p:nvPr/>
+        </p:nvSpPr>
+        <p:spPr>
+          <a:xfrm>
+            <a:off x="1051560" y="4032504"/>
+            <a:ext cx="3383280" cy="475488"/>
+          </a:xfrm>
+          <a:prstGeom prst="rect">
+            <a:avLst/>
+          </a:prstGeom>
+          <a:noFill/>
+        </p:spPr>
+        <p:txBody>
+          <a:bodyPr wrap="square" anchor="ctr" lIns="0" rIns="0" tIns="0" bIns="0">
+            <a:spAutoFit/>
+          </a:bodyPr>
+          <a:lstStyle/>
+          <a:p>
+            <a:pPr algn="l">
+              <a:spcAft>
+                <a:spcPts val="0"/>
+              </a:spcAft>
+            </a:pPr>
+            <a:r>
+              <a:rPr sz="1150" b="0">
+                <a:solidFill>
+                  <a:srgbClr val="222B36"/>
+                </a:solidFill>
+                <a:latin typeface="Calibri"/>
+              </a:rPr>
+              <a:t>Coût d'installation (CAPEX)</a:t>
+            </a:r>
+          </a:p>
+        </p:txBody>
+      </p:sp>
+      <p:sp>
+        <p:nvSpPr>
+          <p:cNvPr id="30" name="Rectangle 29"/>
+          <p:cNvSpPr/>
+          <p:nvPr/>
+        </p:nvSpPr>
+        <p:spPr>
+          <a:xfrm>
+            <a:off x="4572000" y="4032504"/>
+            <a:ext cx="2377440" cy="475488"/>
+          </a:xfrm>
+          <a:prstGeom prst="rect">
+            <a:avLst/>
+          </a:prstGeom>
+          <a:solidFill>
+            <a:srgbClr val="FFFFFF"/>
+          </a:solidFill>
+          <a:ln>
+            <a:noFill/>
+          </a:ln>
+          <a:effectLst/>
+        </p:spPr>
+        <p:style>
+          <a:lnRef idx="1">
+            <a:schemeClr val="accent1"/>
+          </a:lnRef>
+          <a:fillRef idx="3">
+            <a:schemeClr val="accent1"/>
+          </a:fillRef>
+          <a:effectRef idx="2">
+            <a:schemeClr val="accent1"/>
+          </a:effectRef>
+          <a:fontRef idx="minor">
+            <a:schemeClr val="lt1"/>
+          </a:fontRef>
+        </p:style>
+        <p:txBody>
+          <a:bodyPr rtlCol="0" anchor="ctr"/>
+          <a:lstStyle/>
+          <a:p>
+            <a:pPr algn="ctr"/>
+          </a:p>
+        </p:txBody>
+      </p:sp>
+      <p:sp>
+        <p:nvSpPr>
+          <p:cNvPr id="31" name="TextBox 30"/>
+          <p:cNvSpPr txBox="1"/>
+          <p:nvPr/>
+        </p:nvSpPr>
+        <p:spPr>
+          <a:xfrm>
+            <a:off x="4709160" y="4032504"/>
+            <a:ext cx="2103120" cy="475488"/>
+          </a:xfrm>
+          <a:prstGeom prst="rect">
+            <a:avLst/>
+          </a:prstGeom>
+          <a:noFill/>
+        </p:spPr>
+        <p:txBody>
+          <a:bodyPr wrap="square" anchor="ctr" lIns="0" rIns="0" tIns="0" bIns="0">
+            <a:spAutoFit/>
+          </a:bodyPr>
+          <a:lstStyle/>
+          <a:p>
+            <a:pPr algn="l">
+              <a:spcAft>
+                <a:spcPts val="0"/>
+              </a:spcAft>
+            </a:pPr>
+            <a:r>
+              <a:rPr sz="1150" b="1">
+                <a:solidFill>
+                  <a:srgbClr val="0E7C7B"/>
+                </a:solidFill>
+                <a:latin typeface="Calibri"/>
+              </a:rPr>
+              <a:t>1100–1850 €/kWc</a:t>
+            </a:r>
+          </a:p>
+        </p:txBody>
+      </p:sp>
+      <p:sp>
+        <p:nvSpPr>
+          <p:cNvPr id="32" name="Rectangle 31"/>
+          <p:cNvSpPr/>
+          <p:nvPr/>
+        </p:nvSpPr>
+        <p:spPr>
+          <a:xfrm>
+            <a:off x="6949440" y="4032504"/>
+            <a:ext cx="4389120" cy="475488"/>
+          </a:xfrm>
+          <a:prstGeom prst="rect">
+            <a:avLst/>
+          </a:prstGeom>
+          <a:solidFill>
+            <a:srgbClr val="FFFFFF"/>
+          </a:solidFill>
+          <a:ln>
+            <a:noFill/>
+          </a:ln>
+          <a:effectLst/>
+        </p:spPr>
+        <p:style>
+          <a:lnRef idx="1">
+            <a:schemeClr val="accent1"/>
+          </a:lnRef>
+          <a:fillRef idx="3">
+            <a:schemeClr val="accent1"/>
+          </a:fillRef>
+          <a:effectRef idx="2">
+            <a:schemeClr val="accent1"/>
+          </a:effectRef>
+          <a:fontRef idx="minor">
+            <a:schemeClr val="lt1"/>
+          </a:fontRef>
+        </p:style>
+        <p:txBody>
+          <a:bodyPr rtlCol="0" anchor="ctr"/>
+          <a:lstStyle/>
+          <a:p>
+            <a:pPr algn="ctr"/>
+          </a:p>
+        </p:txBody>
+      </p:sp>
+      <p:sp>
+        <p:nvSpPr>
+          <p:cNvPr id="33" name="TextBox 32"/>
+          <p:cNvSpPr txBox="1"/>
+          <p:nvPr/>
+        </p:nvSpPr>
+        <p:spPr>
+          <a:xfrm>
+            <a:off x="7086600" y="4032504"/>
+            <a:ext cx="4114800" cy="475488"/>
+          </a:xfrm>
+          <a:prstGeom prst="rect">
+            <a:avLst/>
+          </a:prstGeom>
+          <a:noFill/>
+        </p:spPr>
+        <p:txBody>
+          <a:bodyPr wrap="square" anchor="ctr" lIns="0" rIns="0" tIns="0" bIns="0">
+            <a:spAutoFit/>
+          </a:bodyPr>
+          <a:lstStyle/>
+          <a:p>
+            <a:pPr algn="l">
+              <a:spcAft>
+                <a:spcPts val="0"/>
+              </a:spcAft>
+            </a:pPr>
+            <a:r>
+              <a:rPr sz="1150" b="0">
+                <a:solidFill>
+                  <a:srgbClr val="222B36"/>
+                </a:solidFill>
+                <a:latin typeface="Calibri"/>
+              </a:rPr>
+              <a:t>Fourchettes de marché selon la taille</a:t>
+            </a:r>
+          </a:p>
+        </p:txBody>
+      </p:sp>
+      <p:sp>
+        <p:nvSpPr>
+          <p:cNvPr id="34" name="Rectangle 33"/>
+          <p:cNvSpPr/>
+          <p:nvPr/>
+        </p:nvSpPr>
+        <p:spPr>
+          <a:xfrm>
+            <a:off x="914400" y="4507992"/>
+            <a:ext cx="3657600" cy="475488"/>
+          </a:xfrm>
+          <a:prstGeom prst="rect">
+            <a:avLst/>
+          </a:prstGeom>
+          <a:solidFill>
+            <a:srgbClr val="F5F8F7"/>
+          </a:solidFill>
+          <a:ln>
+            <a:noFill/>
+          </a:ln>
+          <a:effectLst/>
+        </p:spPr>
+        <p:style>
+          <a:lnRef idx="1">
+            <a:schemeClr val="accent1"/>
+          </a:lnRef>
+          <a:fillRef idx="3">
+            <a:schemeClr val="accent1"/>
+          </a:fillRef>
+          <a:effectRef idx="2">
+            <a:schemeClr val="accent1"/>
+          </a:effectRef>
+          <a:fontRef idx="minor">
+            <a:schemeClr val="lt1"/>
+          </a:fontRef>
+        </p:style>
+        <p:txBody>
+          <a:bodyPr rtlCol="0" anchor="ctr"/>
+          <a:lstStyle/>
+          <a:p>
+            <a:pPr algn="ctr"/>
+          </a:p>
+        </p:txBody>
+      </p:sp>
+      <p:sp>
+        <p:nvSpPr>
+          <p:cNvPr id="35" name="TextBox 34"/>
+          <p:cNvSpPr txBox="1"/>
+          <p:nvPr/>
+        </p:nvSpPr>
+        <p:spPr>
+          <a:xfrm>
+            <a:off x="1051560" y="4507992"/>
+            <a:ext cx="3383280" cy="475488"/>
+          </a:xfrm>
+          <a:prstGeom prst="rect">
+            <a:avLst/>
+          </a:prstGeom>
+          <a:noFill/>
+        </p:spPr>
+        <p:txBody>
+          <a:bodyPr wrap="square" anchor="ctr" lIns="0" rIns="0" tIns="0" bIns="0">
+            <a:spAutoFit/>
+          </a:bodyPr>
+          <a:lstStyle/>
+          <a:p>
+            <a:pPr algn="l">
+              <a:spcAft>
+                <a:spcPts val="0"/>
+              </a:spcAft>
+            </a:pPr>
+            <a:r>
+              <a:rPr sz="1150" b="0">
+                <a:solidFill>
+                  <a:srgbClr val="222B36"/>
+                </a:solidFill>
+                <a:latin typeface="Calibri"/>
+              </a:rPr>
+              <a:t>Entretien (OPEX)</a:t>
+            </a:r>
+          </a:p>
+        </p:txBody>
+      </p:sp>
+      <p:sp>
+        <p:nvSpPr>
+          <p:cNvPr id="36" name="Rectangle 35"/>
+          <p:cNvSpPr/>
+          <p:nvPr/>
+        </p:nvSpPr>
+        <p:spPr>
+          <a:xfrm>
+            <a:off x="4572000" y="4507992"/>
+            <a:ext cx="2377440" cy="475488"/>
+          </a:xfrm>
+          <a:prstGeom prst="rect">
+            <a:avLst/>
+          </a:prstGeom>
+          <a:solidFill>
+            <a:srgbClr val="F5F8F7"/>
+          </a:solidFill>
+          <a:ln>
+            <a:noFill/>
+          </a:ln>
+          <a:effectLst/>
+        </p:spPr>
+        <p:style>
+          <a:lnRef idx="1">
+            <a:schemeClr val="accent1"/>
+          </a:lnRef>
+          <a:fillRef idx="3">
+            <a:schemeClr val="accent1"/>
+          </a:fillRef>
+          <a:effectRef idx="2">
+            <a:schemeClr val="accent1"/>
+          </a:effectRef>
+          <a:fontRef idx="minor">
+            <a:schemeClr val="lt1"/>
+          </a:fontRef>
+        </p:style>
+        <p:txBody>
+          <a:bodyPr rtlCol="0" anchor="ctr"/>
+          <a:lstStyle/>
+          <a:p>
+            <a:pPr algn="ctr"/>
+          </a:p>
+        </p:txBody>
+      </p:sp>
+      <p:sp>
+        <p:nvSpPr>
+          <p:cNvPr id="37" name="TextBox 36"/>
+          <p:cNvSpPr txBox="1"/>
+          <p:nvPr/>
+        </p:nvSpPr>
+        <p:spPr>
+          <a:xfrm>
+            <a:off x="4709160" y="4507992"/>
+            <a:ext cx="2103120" cy="475488"/>
+          </a:xfrm>
+          <a:prstGeom prst="rect">
+            <a:avLst/>
+          </a:prstGeom>
+          <a:noFill/>
+        </p:spPr>
+        <p:txBody>
+          <a:bodyPr wrap="square" anchor="ctr" lIns="0" rIns="0" tIns="0" bIns="0">
+            <a:spAutoFit/>
+          </a:bodyPr>
+          <a:lstStyle/>
+          <a:p>
+            <a:pPr algn="l">
+              <a:spcAft>
+                <a:spcPts val="0"/>
+              </a:spcAft>
+            </a:pPr>
+            <a:r>
+              <a:rPr sz="1150" b="1">
+                <a:solidFill>
+                  <a:srgbClr val="0E7C7B"/>
+                </a:solidFill>
+                <a:latin typeface="Calibri"/>
+              </a:rPr>
+              <a:t>1,5 %/an</a:t>
+            </a:r>
+          </a:p>
+        </p:txBody>
+      </p:sp>
+      <p:sp>
+        <p:nvSpPr>
+          <p:cNvPr id="38" name="Rectangle 37"/>
+          <p:cNvSpPr/>
+          <p:nvPr/>
+        </p:nvSpPr>
+        <p:spPr>
+          <a:xfrm>
+            <a:off x="6949440" y="4507992"/>
+            <a:ext cx="4389120" cy="475488"/>
+          </a:xfrm>
+          <a:prstGeom prst="rect">
+            <a:avLst/>
+          </a:prstGeom>
+          <a:solidFill>
+            <a:srgbClr val="F5F8F7"/>
+          </a:solidFill>
+          <a:ln>
+            <a:noFill/>
+          </a:ln>
+          <a:effectLst/>
+        </p:spPr>
+        <p:style>
+          <a:lnRef idx="1">
+            <a:schemeClr val="accent1"/>
+          </a:lnRef>
+          <a:fillRef idx="3">
+            <a:schemeClr val="accent1"/>
+          </a:fillRef>
+          <a:effectRef idx="2">
+            <a:schemeClr val="accent1"/>
+          </a:effectRef>
+          <a:fontRef idx="minor">
+            <a:schemeClr val="lt1"/>
+          </a:fontRef>
+        </p:style>
+        <p:txBody>
+          <a:bodyPr rtlCol="0" anchor="ctr"/>
+          <a:lstStyle/>
+          <a:p>
+            <a:pPr algn="ctr"/>
+          </a:p>
+        </p:txBody>
+      </p:sp>
+      <p:sp>
+        <p:nvSpPr>
+          <p:cNvPr id="39" name="TextBox 38"/>
+          <p:cNvSpPr txBox="1"/>
+          <p:nvPr/>
+        </p:nvSpPr>
+        <p:spPr>
+          <a:xfrm>
+            <a:off x="7086600" y="4507992"/>
+            <a:ext cx="4114800" cy="475488"/>
+          </a:xfrm>
+          <a:prstGeom prst="rect">
+            <a:avLst/>
+          </a:prstGeom>
+          <a:noFill/>
+        </p:spPr>
+        <p:txBody>
+          <a:bodyPr wrap="square" anchor="ctr" lIns="0" rIns="0" tIns="0" bIns="0">
+            <a:spAutoFit/>
+          </a:bodyPr>
+          <a:lstStyle/>
+          <a:p>
+            <a:pPr algn="l">
+              <a:spcAft>
+                <a:spcPts val="0"/>
+              </a:spcAft>
+            </a:pPr>
+            <a:r>
+              <a:rPr sz="1150" b="0">
+                <a:solidFill>
+                  <a:srgbClr val="222B36"/>
+                </a:solidFill>
+                <a:latin typeface="Calibri"/>
+              </a:rPr>
+              <a:t>Maintenance courante d'une installation PV</a:t>
+            </a:r>
+          </a:p>
+        </p:txBody>
+      </p:sp>
+      <p:sp>
+        <p:nvSpPr>
+          <p:cNvPr id="40" name="Rectangle 39"/>
+          <p:cNvSpPr/>
+          <p:nvPr/>
+        </p:nvSpPr>
+        <p:spPr>
+          <a:xfrm>
+            <a:off x="914400" y="4983480"/>
+            <a:ext cx="3657600" cy="475488"/>
+          </a:xfrm>
+          <a:prstGeom prst="rect">
+            <a:avLst/>
+          </a:prstGeom>
+          <a:solidFill>
+            <a:srgbClr val="FFFFFF"/>
+          </a:solidFill>
+          <a:ln>
+            <a:noFill/>
+          </a:ln>
+          <a:effectLst/>
+        </p:spPr>
+        <p:style>
+          <a:lnRef idx="1">
+            <a:schemeClr val="accent1"/>
+          </a:lnRef>
+          <a:fillRef idx="3">
+            <a:schemeClr val="accent1"/>
+          </a:fillRef>
+          <a:effectRef idx="2">
+            <a:schemeClr val="accent1"/>
+          </a:effectRef>
+          <a:fontRef idx="minor">
+            <a:schemeClr val="lt1"/>
+          </a:fontRef>
+        </p:style>
+        <p:txBody>
+          <a:bodyPr rtlCol="0" anchor="ctr"/>
+          <a:lstStyle/>
+          <a:p>
+            <a:pPr algn="ctr"/>
+          </a:p>
+        </p:txBody>
+      </p:sp>
+      <p:sp>
+        <p:nvSpPr>
+          <p:cNvPr id="41" name="TextBox 40"/>
+          <p:cNvSpPr txBox="1"/>
+          <p:nvPr/>
+        </p:nvSpPr>
+        <p:spPr>
+          <a:xfrm>
+            <a:off x="1051560" y="4983480"/>
+            <a:ext cx="3383280" cy="475488"/>
+          </a:xfrm>
+          <a:prstGeom prst="rect">
+            <a:avLst/>
+          </a:prstGeom>
+          <a:noFill/>
+        </p:spPr>
+        <p:txBody>
+          <a:bodyPr wrap="square" anchor="ctr" lIns="0" rIns="0" tIns="0" bIns="0">
+            <a:spAutoFit/>
+          </a:bodyPr>
+          <a:lstStyle/>
+          <a:p>
+            <a:pPr algn="l">
+              <a:spcAft>
+                <a:spcPts val="0"/>
+              </a:spcAft>
+            </a:pPr>
+            <a:r>
+              <a:rPr sz="1150" b="0">
+                <a:solidFill>
+                  <a:srgbClr val="222B36"/>
+                </a:solidFill>
+                <a:latin typeface="Calibri"/>
+              </a:rPr>
+              <a:t>Taux d'autoconsommation</a:t>
+            </a:r>
+          </a:p>
+        </p:txBody>
+      </p:sp>
+      <p:sp>
+        <p:nvSpPr>
+          <p:cNvPr id="42" name="Rectangle 41"/>
+          <p:cNvSpPr/>
+          <p:nvPr/>
+        </p:nvSpPr>
+        <p:spPr>
+          <a:xfrm>
+            <a:off x="4572000" y="4983480"/>
+            <a:ext cx="2377440" cy="475488"/>
+          </a:xfrm>
+          <a:prstGeom prst="rect">
+            <a:avLst/>
+          </a:prstGeom>
+          <a:solidFill>
+            <a:srgbClr val="FFFFFF"/>
+          </a:solidFill>
+          <a:ln>
+            <a:noFill/>
+          </a:ln>
+          <a:effectLst/>
+        </p:spPr>
+        <p:style>
+          <a:lnRef idx="1">
+            <a:schemeClr val="accent1"/>
+          </a:lnRef>
+          <a:fillRef idx="3">
+            <a:schemeClr val="accent1"/>
+          </a:fillRef>
+          <a:effectRef idx="2">
+            <a:schemeClr val="accent1"/>
+          </a:effectRef>
+          <a:fontRef idx="minor">
+            <a:schemeClr val="lt1"/>
+          </a:fontRef>
+        </p:style>
+        <p:txBody>
+          <a:bodyPr rtlCol="0" anchor="ctr"/>
+          <a:lstStyle/>
+          <a:p>
+            <a:pPr algn="ctr"/>
+          </a:p>
+        </p:txBody>
+      </p:sp>
+      <p:sp>
+        <p:nvSpPr>
+          <p:cNvPr id="43" name="TextBox 42"/>
+          <p:cNvSpPr txBox="1"/>
+          <p:nvPr/>
+        </p:nvSpPr>
+        <p:spPr>
+          <a:xfrm>
+            <a:off x="4709160" y="4983480"/>
+            <a:ext cx="2103120" cy="475488"/>
+          </a:xfrm>
+          <a:prstGeom prst="rect">
+            <a:avLst/>
+          </a:prstGeom>
+          <a:noFill/>
+        </p:spPr>
+        <p:txBody>
+          <a:bodyPr wrap="square" anchor="ctr" lIns="0" rIns="0" tIns="0" bIns="0">
+            <a:spAutoFit/>
+          </a:bodyPr>
+          <a:lstStyle/>
+          <a:p>
+            <a:pPr algn="l">
+              <a:spcAft>
+                <a:spcPts val="0"/>
+              </a:spcAft>
+            </a:pPr>
+            <a:r>
+              <a:rPr sz="1150" b="1">
+                <a:solidFill>
+                  <a:srgbClr val="0E7C7B"/>
+                </a:solidFill>
+                <a:latin typeface="Calibri"/>
+              </a:rPr>
+              <a:t>65 %</a:t>
+            </a:r>
+          </a:p>
+        </p:txBody>
+      </p:sp>
+      <p:sp>
+        <p:nvSpPr>
+          <p:cNvPr id="44" name="Rectangle 43"/>
+          <p:cNvSpPr/>
+          <p:nvPr/>
+        </p:nvSpPr>
+        <p:spPr>
+          <a:xfrm>
+            <a:off x="6949440" y="4983480"/>
+            <a:ext cx="4389120" cy="475488"/>
+          </a:xfrm>
+          <a:prstGeom prst="rect">
+            <a:avLst/>
+          </a:prstGeom>
+          <a:solidFill>
+            <a:srgbClr val="FFFFFF"/>
+          </a:solidFill>
+          <a:ln>
+            <a:noFill/>
+          </a:ln>
+          <a:effectLst/>
+        </p:spPr>
+        <p:style>
+          <a:lnRef idx="1">
+            <a:schemeClr val="accent1"/>
+          </a:lnRef>
+          <a:fillRef idx="3">
+            <a:schemeClr val="accent1"/>
+          </a:fillRef>
+          <a:effectRef idx="2">
+            <a:schemeClr val="accent1"/>
+          </a:effectRef>
+          <a:fontRef idx="minor">
+            <a:schemeClr val="lt1"/>
+          </a:fontRef>
+        </p:style>
+        <p:txBody>
+          <a:bodyPr rtlCol="0" anchor="ctr"/>
+          <a:lstStyle/>
+          <a:p>
+            <a:pPr algn="ctr"/>
+          </a:p>
+        </p:txBody>
+      </p:sp>
+      <p:sp>
+        <p:nvSpPr>
+          <p:cNvPr id="45" name="TextBox 44"/>
+          <p:cNvSpPr txBox="1"/>
+          <p:nvPr/>
+        </p:nvSpPr>
+        <p:spPr>
+          <a:xfrm>
+            <a:off x="7086600" y="4983480"/>
+            <a:ext cx="4114800" cy="475488"/>
+          </a:xfrm>
+          <a:prstGeom prst="rect">
+            <a:avLst/>
+          </a:prstGeom>
+          <a:noFill/>
+        </p:spPr>
+        <p:txBody>
+          <a:bodyPr wrap="square" anchor="ctr" lIns="0" rIns="0" tIns="0" bIns="0">
+            <a:spAutoFit/>
+          </a:bodyPr>
+          <a:lstStyle/>
+          <a:p>
+            <a:pPr algn="l">
+              <a:spcAft>
+                <a:spcPts val="0"/>
+              </a:spcAft>
+            </a:pPr>
+            <a:r>
+              <a:rPr sz="1150" b="0">
+                <a:solidFill>
+                  <a:srgbClr val="222B36"/>
+                </a:solidFill>
+                <a:latin typeface="Calibri"/>
+              </a:rPr>
+              <a:t>Usage réaliste pour du tertiaire</a:t>
+            </a:r>
+          </a:p>
+        </p:txBody>
+      </p:sp>
+      <p:sp>
+        <p:nvSpPr>
+          <p:cNvPr id="46" name="Rectangle 45"/>
+          <p:cNvSpPr/>
+          <p:nvPr/>
+        </p:nvSpPr>
+        <p:spPr>
+          <a:xfrm>
+            <a:off x="914400" y="5458968"/>
+            <a:ext cx="3657600" cy="475488"/>
+          </a:xfrm>
+          <a:prstGeom prst="rect">
+            <a:avLst/>
+          </a:prstGeom>
+          <a:solidFill>
+            <a:srgbClr val="F5F8F7"/>
+          </a:solidFill>
+          <a:ln>
+            <a:noFill/>
+          </a:ln>
+          <a:effectLst/>
+        </p:spPr>
+        <p:style>
+          <a:lnRef idx="1">
+            <a:schemeClr val="accent1"/>
+          </a:lnRef>
+          <a:fillRef idx="3">
+            <a:schemeClr val="accent1"/>
+          </a:fillRef>
+          <a:effectRef idx="2">
+            <a:schemeClr val="accent1"/>
+          </a:effectRef>
+          <a:fontRef idx="minor">
+            <a:schemeClr val="lt1"/>
+          </a:fontRef>
+        </p:style>
+        <p:txBody>
+          <a:bodyPr rtlCol="0" anchor="ctr"/>
+          <a:lstStyle/>
+          <a:p>
+            <a:pPr algn="ctr"/>
+          </a:p>
+        </p:txBody>
+      </p:sp>
+      <p:sp>
+        <p:nvSpPr>
+          <p:cNvPr id="47" name="TextBox 46"/>
+          <p:cNvSpPr txBox="1"/>
+          <p:nvPr/>
+        </p:nvSpPr>
+        <p:spPr>
+          <a:xfrm>
+            <a:off x="1051560" y="5458968"/>
+            <a:ext cx="3383280" cy="475488"/>
+          </a:xfrm>
+          <a:prstGeom prst="rect">
+            <a:avLst/>
+          </a:prstGeom>
+          <a:noFill/>
+        </p:spPr>
+        <p:txBody>
+          <a:bodyPr wrap="square" anchor="ctr" lIns="0" rIns="0" tIns="0" bIns="0">
+            <a:spAutoFit/>
+          </a:bodyPr>
+          <a:lstStyle/>
+          <a:p>
+            <a:pPr algn="l">
+              <a:spcAft>
+                <a:spcPts val="0"/>
+              </a:spcAft>
+            </a:pPr>
+            <a:r>
+              <a:rPr sz="1150" b="0">
+                <a:solidFill>
+                  <a:srgbClr val="222B36"/>
+                </a:solidFill>
+                <a:latin typeface="Calibri"/>
+              </a:rPr>
+              <a:t>Taux d'actualisation</a:t>
+            </a:r>
+          </a:p>
+        </p:txBody>
+      </p:sp>
+      <p:sp>
+        <p:nvSpPr>
+          <p:cNvPr id="48" name="Rectangle 47"/>
+          <p:cNvSpPr/>
+          <p:nvPr/>
+        </p:nvSpPr>
+        <p:spPr>
+          <a:xfrm>
+            <a:off x="4572000" y="5458968"/>
+            <a:ext cx="2377440" cy="475488"/>
+          </a:xfrm>
+          <a:prstGeom prst="rect">
+            <a:avLst/>
+          </a:prstGeom>
+          <a:solidFill>
+            <a:srgbClr val="F5F8F7"/>
+          </a:solidFill>
+          <a:ln>
+            <a:noFill/>
+          </a:ln>
+          <a:effectLst/>
+        </p:spPr>
+        <p:style>
+          <a:lnRef idx="1">
+            <a:schemeClr val="accent1"/>
+          </a:lnRef>
+          <a:fillRef idx="3">
+            <a:schemeClr val="accent1"/>
+          </a:fillRef>
+          <a:effectRef idx="2">
+            <a:schemeClr val="accent1"/>
+          </a:effectRef>
+          <a:fontRef idx="minor">
+            <a:schemeClr val="lt1"/>
+          </a:fontRef>
+        </p:style>
+        <p:txBody>
+          <a:bodyPr rtlCol="0" anchor="ctr"/>
+          <a:lstStyle/>
+          <a:p>
+            <a:pPr algn="ctr"/>
+          </a:p>
+        </p:txBody>
+      </p:sp>
+      <p:sp>
+        <p:nvSpPr>
+          <p:cNvPr id="49" name="TextBox 48"/>
+          <p:cNvSpPr txBox="1"/>
+          <p:nvPr/>
+        </p:nvSpPr>
+        <p:spPr>
+          <a:xfrm>
+            <a:off x="4709160" y="5458968"/>
+            <a:ext cx="2103120" cy="475488"/>
+          </a:xfrm>
+          <a:prstGeom prst="rect">
+            <a:avLst/>
+          </a:prstGeom>
+          <a:noFill/>
+        </p:spPr>
+        <p:txBody>
+          <a:bodyPr wrap="square" anchor="ctr" lIns="0" rIns="0" tIns="0" bIns="0">
+            <a:spAutoFit/>
+          </a:bodyPr>
+          <a:lstStyle/>
+          <a:p>
+            <a:pPr algn="l">
+              <a:spcAft>
+                <a:spcPts val="0"/>
+              </a:spcAft>
+            </a:pPr>
+            <a:r>
+              <a:rPr sz="1150" b="1">
+                <a:solidFill>
+                  <a:srgbClr val="0E7C7B"/>
+                </a:solidFill>
+                <a:latin typeface="Calibri"/>
+              </a:rPr>
+              <a:t>4 %</a:t>
+            </a:r>
+          </a:p>
+        </p:txBody>
+      </p:sp>
+      <p:sp>
+        <p:nvSpPr>
+          <p:cNvPr id="50" name="Rectangle 49"/>
+          <p:cNvSpPr/>
+          <p:nvPr/>
+        </p:nvSpPr>
+        <p:spPr>
+          <a:xfrm>
+            <a:off x="6949440" y="5458968"/>
+            <a:ext cx="4389120" cy="475488"/>
+          </a:xfrm>
+          <a:prstGeom prst="rect">
+            <a:avLst/>
+          </a:prstGeom>
+          <a:solidFill>
+            <a:srgbClr val="F5F8F7"/>
+          </a:solidFill>
+          <a:ln>
+            <a:noFill/>
+          </a:ln>
+          <a:effectLst/>
+        </p:spPr>
+        <p:style>
+          <a:lnRef idx="1">
+            <a:schemeClr val="accent1"/>
+          </a:lnRef>
+          <a:fillRef idx="3">
+            <a:schemeClr val="accent1"/>
+          </a:fillRef>
+          <a:effectRef idx="2">
+            <a:schemeClr val="accent1"/>
+          </a:effectRef>
+          <a:fontRef idx="minor">
+            <a:schemeClr val="lt1"/>
+          </a:fontRef>
+        </p:style>
+        <p:txBody>
+          <a:bodyPr rtlCol="0" anchor="ctr"/>
+          <a:lstStyle/>
+          <a:p>
+            <a:pPr algn="ctr"/>
+          </a:p>
+        </p:txBody>
+      </p:sp>
+      <p:sp>
+        <p:nvSpPr>
+          <p:cNvPr id="51" name="TextBox 50"/>
+          <p:cNvSpPr txBox="1"/>
+          <p:nvPr/>
+        </p:nvSpPr>
+        <p:spPr>
+          <a:xfrm>
+            <a:off x="7086600" y="5458968"/>
+            <a:ext cx="4114800" cy="475488"/>
+          </a:xfrm>
+          <a:prstGeom prst="rect">
+            <a:avLst/>
+          </a:prstGeom>
+          <a:noFill/>
+        </p:spPr>
+        <p:txBody>
+          <a:bodyPr wrap="square" anchor="ctr" lIns="0" rIns="0" tIns="0" bIns="0">
+            <a:spAutoFit/>
+          </a:bodyPr>
+          <a:lstStyle/>
+          <a:p>
+            <a:pPr algn="l">
+              <a:spcAft>
+                <a:spcPts val="0"/>
+              </a:spcAft>
+            </a:pPr>
+            <a:r>
+              <a:rPr sz="1150" b="0">
+                <a:solidFill>
+                  <a:srgbClr val="222B36"/>
+                </a:solidFill>
+                <a:latin typeface="Calibri"/>
+              </a:rPr>
+              <a:t>Standard d'analyse d'investissement</a:t>
+            </a:r>
+          </a:p>
+        </p:txBody>
+      </p:sp>
+      <p:sp>
+        <p:nvSpPr>
+          <p:cNvPr id="52" name="TextBox 51"/>
+          <p:cNvSpPr txBox="1"/>
+          <p:nvPr/>
+        </p:nvSpPr>
+        <p:spPr>
+          <a:xfrm>
+            <a:off x="914400" y="6071616"/>
+            <a:ext cx="10424160" cy="548640"/>
+          </a:xfrm>
+          <a:prstGeom prst="rect">
+            <a:avLst/>
+          </a:prstGeom>
+          <a:noFill/>
+        </p:spPr>
+        <p:txBody>
+          <a:bodyPr wrap="square" anchor="t" lIns="0" rIns="0" tIns="0" bIns="0">
+            <a:spAutoFit/>
+          </a:bodyPr>
+          <a:lstStyle/>
+          <a:p>
+            <a:pPr algn="l">
+              <a:spcAft>
+                <a:spcPts val="0"/>
+              </a:spcAft>
+            </a:pPr>
+            <a:r>
+              <a:rPr sz="1200" b="0">
+                <a:solidFill>
+                  <a:srgbClr val="647486"/>
+                </a:solidFill>
+                <a:latin typeface="Calibri"/>
+              </a:rPr>
+              <a:t>Source principale : note de cadrage (Annexe A) — ordres de grandeur de marché. La production, elle, vient de PVGIS (réel).</a:t>
             </a:r>
           </a:p>
         </p:txBody>

</xml_diff>

<commit_message>
docs: ajout des liens dashboard deploye et depot GitHub (README, dossier technique, presentation)
</commit_message>
<xml_diff>
--- a/docs/exports/soutenance-workshop-pv.pptx
+++ b/docs/exports/soutenance-workshop-pv.pptx
@@ -5250,6 +5250,50 @@
                 <a:latin typeface="Calibri"/>
               </a:rPr>
               <a:t> d'un département et exporter les données.</a:t>
+            </a:r>
+          </a:p>
+        </p:txBody>
+      </p:sp>
+      <p:sp>
+        <p:nvSpPr>
+          <p:cNvPr id="11" name="TextBox 10"/>
+          <p:cNvSpPr txBox="1"/>
+          <p:nvPr/>
+        </p:nvSpPr>
+        <p:spPr>
+          <a:xfrm>
+            <a:off x="914400" y="5623560"/>
+            <a:ext cx="10332720" cy="640080"/>
+          </a:xfrm>
+          <a:prstGeom prst="rect">
+            <a:avLst/>
+          </a:prstGeom>
+          <a:noFill/>
+        </p:spPr>
+        <p:txBody>
+          <a:bodyPr wrap="square">
+            <a:spAutoFit/>
+          </a:bodyPr>
+          <a:lstStyle/>
+          <a:p>
+            <a:pPr algn="l"/>
+            <a:r>
+              <a:rPr sz="1400" b="1">
+                <a:solidFill>
+                  <a:srgbClr val="222B36"/>
+                </a:solidFill>
+                <a:latin typeface="Calibri"/>
+              </a:rPr>
+              <a:t>À tester en direct : </a:t>
+            </a:r>
+            <a:r>
+              <a:rPr sz="1400" b="1">
+                <a:solidFill>
+                  <a:srgbClr val="F2A900"/>
+                </a:solidFill>
+                <a:latin typeface="Calibri"/>
+              </a:rPr>
+              <a:t>https://imeneee01-workshop-client-3-streamlit-app-kzifeo.streamlit.app/</a:t>
             </a:r>
           </a:p>
         </p:txBody>

</xml_diff>

<commit_message>
docs: ajout d'une slide gestion de projet (planning, suivi, risques/qualite)
</commit_message>
<xml_diff>
--- a/docs/exports/soutenance-workshop-pv.pptx
+++ b/docs/exports/soutenance-workshop-pv.pptx
@@ -13,6 +13,7 @@
     <p:sldId id="258" r:id="rId4"/>
     <p:sldId id="259" r:id="rId5"/>
     <p:sldId id="260" r:id="rId6"/>
+    <p:sldId id="269" r:id="rId20"/>
     <p:sldId id="261" r:id="rId7"/>
     <p:sldId id="262" r:id="rId8"/>
     <p:sldId id="263" r:id="rId9"/>
@@ -6239,6 +6240,503 @@
                 <a:latin typeface="Calibri"/>
               </a:rPr>
               <a:t>Imene BELHOCINE   ·   Workshop client — Oxand   ·   MBA M2 Big Data &amp; IA</a:t>
+            </a:r>
+          </a:p>
+        </p:txBody>
+      </p:sp>
+    </p:spTree>
+  </p:cSld>
+  <p:clrMapOvr>
+    <a:masterClrMapping/>
+  </p:clrMapOvr>
+</p:sld>
+</file>
+
+<file path=ppt/slides/slide13.xml><?xml version="1.0" encoding="utf-8"?>
+<p:sld xmlns:a="http://schemas.openxmlformats.org/drawingml/2006/main" xmlns:p="http://schemas.openxmlformats.org/presentationml/2006/main" xmlns:r="http://schemas.openxmlformats.org/officeDocument/2006/relationships">
+  <p:cSld>
+    <p:bg>
+      <p:bgPr>
+        <a:solidFill>
+          <a:srgbClr val="FFFFFF"/>
+        </a:solidFill>
+        <a:effectLst/>
+      </p:bgPr>
+    </p:bg>
+    <p:spTree>
+      <p:nvGrpSpPr>
+        <p:cNvPr id="1" name=""/>
+        <p:cNvGrpSpPr/>
+        <p:nvPr/>
+      </p:nvGrpSpPr>
+      <p:grpSpPr/>
+      <p:sp>
+        <p:nvSpPr>
+          <p:cNvPr id="2" name="TextBox 1"/>
+          <p:cNvSpPr txBox="1"/>
+          <p:nvPr/>
+        </p:nvSpPr>
+        <p:spPr>
+          <a:xfrm>
+            <a:off x="914400" y="640080"/>
+            <a:ext cx="10972800" cy="822960"/>
+          </a:xfrm>
+          <a:prstGeom prst="rect">
+            <a:avLst/>
+          </a:prstGeom>
+          <a:noFill/>
+        </p:spPr>
+        <p:txBody>
+          <a:bodyPr wrap="square" anchor="t" lIns="0" rIns="0" tIns="0" bIns="0">
+            <a:spAutoFit/>
+          </a:bodyPr>
+          <a:lstStyle/>
+          <a:p>
+            <a:pPr algn="l">
+              <a:spcAft>
+                <a:spcPts val="0"/>
+              </a:spcAft>
+            </a:pPr>
+            <a:r>
+              <a:rPr sz="3000" b="1">
+                <a:solidFill>
+                  <a:srgbClr val="12293D"/>
+                </a:solidFill>
+                <a:latin typeface="Cambria"/>
+              </a:rPr>
+              <a:t>Gestion du projet</a:t>
+            </a:r>
+          </a:p>
+        </p:txBody>
+      </p:sp>
+      <p:sp>
+        <p:nvSpPr>
+          <p:cNvPr id="3" name="TextBox 2"/>
+          <p:cNvSpPr txBox="1"/>
+          <p:nvPr/>
+        </p:nvSpPr>
+        <p:spPr>
+          <a:xfrm>
+            <a:off x="914400" y="1508760"/>
+            <a:ext cx="10424160" cy="457200"/>
+          </a:xfrm>
+          <a:prstGeom prst="rect">
+            <a:avLst/>
+          </a:prstGeom>
+          <a:noFill/>
+        </p:spPr>
+        <p:txBody>
+          <a:bodyPr wrap="square" anchor="t" lIns="0" rIns="0" tIns="0" bIns="0">
+            <a:spAutoFit/>
+          </a:bodyPr>
+          <a:lstStyle/>
+          <a:p>
+            <a:pPr algn="l">
+              <a:spcAft>
+                <a:spcPts val="0"/>
+              </a:spcAft>
+            </a:pPr>
+            <a:r>
+              <a:rPr sz="1400" b="0">
+                <a:solidFill>
+                  <a:srgbClr val="647486"/>
+                </a:solidFill>
+                <a:latin typeface="Calibri"/>
+              </a:rPr>
+              <a:t>Un projet mené en autonomie, piloté comme une mission d'agence.</a:t>
+            </a:r>
+          </a:p>
+        </p:txBody>
+      </p:sp>
+      <p:sp>
+        <p:nvSpPr>
+          <p:cNvPr id="4" name="Rounded Rectangle 3"/>
+          <p:cNvSpPr/>
+          <p:nvPr/>
+        </p:nvSpPr>
+        <p:spPr>
+          <a:xfrm>
+            <a:off x="914400" y="2194560"/>
+            <a:ext cx="3383280" cy="2834640"/>
+          </a:xfrm>
+          <a:prstGeom prst="roundRect">
+            <a:avLst/>
+          </a:prstGeom>
+          <a:solidFill>
+            <a:srgbClr val="F5F8F7"/>
+          </a:solidFill>
+          <a:ln>
+            <a:noFill/>
+          </a:ln>
+          <a:effectLst>
+            <a:outerShdw blurRad="60000" dist="20000" dir="5400000" rotWithShape="0">
+              <a:srgbClr val="12293D">
+                <a:alpha val="14000"/>
+              </a:srgbClr>
+            </a:outerShdw>
+          </a:effectLst>
+        </p:spPr>
+        <p:style>
+          <a:lnRef idx="1">
+            <a:schemeClr val="accent1"/>
+          </a:lnRef>
+          <a:fillRef idx="3">
+            <a:schemeClr val="accent1"/>
+          </a:fillRef>
+          <a:effectRef idx="2">
+            <a:schemeClr val="accent1"/>
+          </a:effectRef>
+          <a:fontRef idx="minor">
+            <a:schemeClr val="lt1"/>
+          </a:fontRef>
+        </p:style>
+        <p:txBody>
+          <a:bodyPr rtlCol="0" anchor="ctr"/>
+          <a:lstStyle/>
+          <a:p>
+            <a:pPr algn="ctr"/>
+          </a:p>
+        </p:txBody>
+      </p:sp>
+      <p:sp>
+        <p:nvSpPr>
+          <p:cNvPr id="5" name="TextBox 4"/>
+          <p:cNvSpPr txBox="1"/>
+          <p:nvPr/>
+        </p:nvSpPr>
+        <p:spPr>
+          <a:xfrm>
+            <a:off x="1188720" y="2514600"/>
+            <a:ext cx="2834640" cy="457200"/>
+          </a:xfrm>
+          <a:prstGeom prst="rect">
+            <a:avLst/>
+          </a:prstGeom>
+          <a:noFill/>
+        </p:spPr>
+        <p:txBody>
+          <a:bodyPr wrap="square" anchor="t" lIns="0" rIns="0" tIns="0" bIns="0">
+            <a:spAutoFit/>
+          </a:bodyPr>
+          <a:lstStyle/>
+          <a:p>
+            <a:pPr algn="l">
+              <a:spcAft>
+                <a:spcPts val="0"/>
+              </a:spcAft>
+            </a:pPr>
+            <a:r>
+              <a:rPr sz="1700" b="1">
+                <a:solidFill>
+                  <a:srgbClr val="0E7C7B"/>
+                </a:solidFill>
+                <a:latin typeface="Cambria"/>
+              </a:rPr>
+              <a:t>Planning</a:t>
+            </a:r>
+          </a:p>
+        </p:txBody>
+      </p:sp>
+      <p:sp>
+        <p:nvSpPr>
+          <p:cNvPr id="6" name="TextBox 5"/>
+          <p:cNvSpPr txBox="1"/>
+          <p:nvPr/>
+        </p:nvSpPr>
+        <p:spPr>
+          <a:xfrm>
+            <a:off x="1188720" y="3246120"/>
+            <a:ext cx="2834640" cy="1554480"/>
+          </a:xfrm>
+          <a:prstGeom prst="rect">
+            <a:avLst/>
+          </a:prstGeom>
+          <a:noFill/>
+        </p:spPr>
+        <p:txBody>
+          <a:bodyPr wrap="square" anchor="t" lIns="0" rIns="0" tIns="0" bIns="0">
+            <a:spAutoFit/>
+          </a:bodyPr>
+          <a:lstStyle/>
+          <a:p>
+            <a:pPr algn="l">
+              <a:lnSpc>
+                <a:spcPct val="112000"/>
+              </a:lnSpc>
+              <a:spcAft>
+                <a:spcPts val="0"/>
+              </a:spcAft>
+            </a:pPr>
+            <a:r>
+              <a:rPr sz="1350" b="0">
+                <a:solidFill>
+                  <a:srgbClr val="222B36"/>
+                </a:solidFill>
+                <a:latin typeface="Calibri"/>
+              </a:rPr>
+              <a:t>Une semaine découpée en jalons : cadrage → données → modèle → dashboard → recettage → dossier.</a:t>
+            </a:r>
+          </a:p>
+        </p:txBody>
+      </p:sp>
+      <p:sp>
+        <p:nvSpPr>
+          <p:cNvPr id="7" name="Rounded Rectangle 6"/>
+          <p:cNvSpPr/>
+          <p:nvPr/>
+        </p:nvSpPr>
+        <p:spPr>
+          <a:xfrm>
+            <a:off x="4663440" y="2194560"/>
+            <a:ext cx="3383280" cy="2834640"/>
+          </a:xfrm>
+          <a:prstGeom prst="roundRect">
+            <a:avLst/>
+          </a:prstGeom>
+          <a:solidFill>
+            <a:srgbClr val="F5F8F7"/>
+          </a:solidFill>
+          <a:ln>
+            <a:noFill/>
+          </a:ln>
+          <a:effectLst>
+            <a:outerShdw blurRad="60000" dist="20000" dir="5400000" rotWithShape="0">
+              <a:srgbClr val="12293D">
+                <a:alpha val="14000"/>
+              </a:srgbClr>
+            </a:outerShdw>
+          </a:effectLst>
+        </p:spPr>
+        <p:style>
+          <a:lnRef idx="1">
+            <a:schemeClr val="accent1"/>
+          </a:lnRef>
+          <a:fillRef idx="3">
+            <a:schemeClr val="accent1"/>
+          </a:fillRef>
+          <a:effectRef idx="2">
+            <a:schemeClr val="accent1"/>
+          </a:effectRef>
+          <a:fontRef idx="minor">
+            <a:schemeClr val="lt1"/>
+          </a:fontRef>
+        </p:style>
+        <p:txBody>
+          <a:bodyPr rtlCol="0" anchor="ctr"/>
+          <a:lstStyle/>
+          <a:p>
+            <a:pPr algn="ctr"/>
+          </a:p>
+        </p:txBody>
+      </p:sp>
+      <p:sp>
+        <p:nvSpPr>
+          <p:cNvPr id="8" name="TextBox 7"/>
+          <p:cNvSpPr txBox="1"/>
+          <p:nvPr/>
+        </p:nvSpPr>
+        <p:spPr>
+          <a:xfrm>
+            <a:off x="4937760" y="2514600"/>
+            <a:ext cx="2834640" cy="457200"/>
+          </a:xfrm>
+          <a:prstGeom prst="rect">
+            <a:avLst/>
+          </a:prstGeom>
+          <a:noFill/>
+        </p:spPr>
+        <p:txBody>
+          <a:bodyPr wrap="square" anchor="t" lIns="0" rIns="0" tIns="0" bIns="0">
+            <a:spAutoFit/>
+          </a:bodyPr>
+          <a:lstStyle/>
+          <a:p>
+            <a:pPr algn="l">
+              <a:spcAft>
+                <a:spcPts val="0"/>
+              </a:spcAft>
+            </a:pPr>
+            <a:r>
+              <a:rPr sz="1700" b="1">
+                <a:solidFill>
+                  <a:srgbClr val="0E7C7B"/>
+                </a:solidFill>
+                <a:latin typeface="Cambria"/>
+              </a:rPr>
+              <a:t>Suivi &amp; client</a:t>
+            </a:r>
+          </a:p>
+        </p:txBody>
+      </p:sp>
+      <p:sp>
+        <p:nvSpPr>
+          <p:cNvPr id="9" name="TextBox 8"/>
+          <p:cNvSpPr txBox="1"/>
+          <p:nvPr/>
+        </p:nvSpPr>
+        <p:spPr>
+          <a:xfrm>
+            <a:off x="4937760" y="3246120"/>
+            <a:ext cx="2834640" cy="1554480"/>
+          </a:xfrm>
+          <a:prstGeom prst="rect">
+            <a:avLst/>
+          </a:prstGeom>
+          <a:noFill/>
+        </p:spPr>
+        <p:txBody>
+          <a:bodyPr wrap="square" anchor="t" lIns="0" rIns="0" tIns="0" bIns="0">
+            <a:spAutoFit/>
+          </a:bodyPr>
+          <a:lstStyle/>
+          <a:p>
+            <a:pPr algn="l">
+              <a:lnSpc>
+                <a:spcPct val="112000"/>
+              </a:lnSpc>
+              <a:spcAft>
+                <a:spcPts val="0"/>
+              </a:spcAft>
+            </a:pPr>
+            <a:r>
+              <a:rPr sz="1350" b="0">
+                <a:solidFill>
+                  <a:srgbClr val="222B36"/>
+                </a:solidFill>
+                <a:latin typeface="Calibri"/>
+              </a:rPr>
+              <a:t>Un board Kanban (To Do / Doing / Done) et un point hebdomadaire avec Oxand.</a:t>
+            </a:r>
+          </a:p>
+        </p:txBody>
+      </p:sp>
+      <p:sp>
+        <p:nvSpPr>
+          <p:cNvPr id="10" name="Rounded Rectangle 9"/>
+          <p:cNvSpPr/>
+          <p:nvPr/>
+        </p:nvSpPr>
+        <p:spPr>
+          <a:xfrm>
+            <a:off x="8412480" y="2194560"/>
+            <a:ext cx="3383280" cy="2834640"/>
+          </a:xfrm>
+          <a:prstGeom prst="roundRect">
+            <a:avLst/>
+          </a:prstGeom>
+          <a:solidFill>
+            <a:srgbClr val="F5F8F7"/>
+          </a:solidFill>
+          <a:ln>
+            <a:noFill/>
+          </a:ln>
+          <a:effectLst>
+            <a:outerShdw blurRad="60000" dist="20000" dir="5400000" rotWithShape="0">
+              <a:srgbClr val="12293D">
+                <a:alpha val="14000"/>
+              </a:srgbClr>
+            </a:outerShdw>
+          </a:effectLst>
+        </p:spPr>
+        <p:style>
+          <a:lnRef idx="1">
+            <a:schemeClr val="accent1"/>
+          </a:lnRef>
+          <a:fillRef idx="3">
+            <a:schemeClr val="accent1"/>
+          </a:fillRef>
+          <a:effectRef idx="2">
+            <a:schemeClr val="accent1"/>
+          </a:effectRef>
+          <a:fontRef idx="minor">
+            <a:schemeClr val="lt1"/>
+          </a:fontRef>
+        </p:style>
+        <p:txBody>
+          <a:bodyPr rtlCol="0" anchor="ctr"/>
+          <a:lstStyle/>
+          <a:p>
+            <a:pPr algn="ctr"/>
+          </a:p>
+        </p:txBody>
+      </p:sp>
+      <p:sp>
+        <p:nvSpPr>
+          <p:cNvPr id="11" name="TextBox 10"/>
+          <p:cNvSpPr txBox="1"/>
+          <p:nvPr/>
+        </p:nvSpPr>
+        <p:spPr>
+          <a:xfrm>
+            <a:off x="8686800" y="2514600"/>
+            <a:ext cx="2834640" cy="457200"/>
+          </a:xfrm>
+          <a:prstGeom prst="rect">
+            <a:avLst/>
+          </a:prstGeom>
+          <a:noFill/>
+        </p:spPr>
+        <p:txBody>
+          <a:bodyPr wrap="square" anchor="t" lIns="0" rIns="0" tIns="0" bIns="0">
+            <a:spAutoFit/>
+          </a:bodyPr>
+          <a:lstStyle/>
+          <a:p>
+            <a:pPr algn="l">
+              <a:spcAft>
+                <a:spcPts val="0"/>
+              </a:spcAft>
+            </a:pPr>
+            <a:r>
+              <a:rPr sz="1700" b="1">
+                <a:solidFill>
+                  <a:srgbClr val="0E7C7B"/>
+                </a:solidFill>
+                <a:latin typeface="Cambria"/>
+              </a:rPr>
+              <a:t>Risques &amp; qualité</a:t>
+            </a:r>
+          </a:p>
+        </p:txBody>
+      </p:sp>
+      <p:sp>
+        <p:nvSpPr>
+          <p:cNvPr id="12" name="TextBox 11"/>
+          <p:cNvSpPr txBox="1"/>
+          <p:nvPr/>
+        </p:nvSpPr>
+        <p:spPr>
+          <a:xfrm>
+            <a:off x="8686800" y="3246120"/>
+            <a:ext cx="2834640" cy="1554480"/>
+          </a:xfrm>
+          <a:prstGeom prst="rect">
+            <a:avLst/>
+          </a:prstGeom>
+          <a:noFill/>
+        </p:spPr>
+        <p:txBody>
+          <a:bodyPr wrap="square" anchor="t" lIns="0" rIns="0" tIns="0" bIns="0">
+            <a:spAutoFit/>
+          </a:bodyPr>
+          <a:lstStyle/>
+          <a:p>
+            <a:pPr algn="l">
+              <a:lnSpc>
+                <a:spcPct val="112000"/>
+              </a:lnSpc>
+              <a:spcAft>
+                <a:spcPts val="0"/>
+              </a:spcAft>
+            </a:pPr>
+            <a:r>
+              <a:rPr sz="1350" b="0">
+                <a:solidFill>
+                  <a:srgbClr val="222B36"/>
+                </a:solidFill>
+                <a:latin typeface="Calibri"/>
+              </a:rPr>
+              <a:t>Risques anticipés (ex. API PVGIS → cache + secours) et 28 tests automatiques.</a:t>
             </a:r>
           </a:p>
         </p:txBody>

</xml_diff>